<commit_message>
Added scripts for graphins simulator data and added final report
</commit_message>
<xml_diff>
--- a/Presentations/week8presentation.pptx
+++ b/Presentations/week8presentation.pptx
@@ -2089,7 +2089,7 @@
           <a:p>
             <a:fld id="{846CE7D5-CF57-46EF-B807-FDD0502418D4}" type="datetimeFigureOut">
               <a:rPr lang="en-US" smtClean="0"/>
-              <a:t>7/2/26</a:t>
+              <a:t>8/4/26</a:t>
             </a:fld>
             <a:endParaRPr lang="en-US"/>
           </a:p>
@@ -2259,7 +2259,7 @@
           <a:p>
             <a:fld id="{846CE7D5-CF57-46EF-B807-FDD0502418D4}" type="datetimeFigureOut">
               <a:rPr lang="en-US" smtClean="0"/>
-              <a:t>7/2/26</a:t>
+              <a:t>8/4/26</a:t>
             </a:fld>
             <a:endParaRPr lang="en-US"/>
           </a:p>
@@ -2439,7 +2439,7 @@
           <a:p>
             <a:fld id="{846CE7D5-CF57-46EF-B807-FDD0502418D4}" type="datetimeFigureOut">
               <a:rPr lang="en-US" smtClean="0"/>
-              <a:t>7/2/26</a:t>
+              <a:t>8/4/26</a:t>
             </a:fld>
             <a:endParaRPr lang="en-US"/>
           </a:p>
@@ -2609,7 +2609,7 @@
           <a:p>
             <a:fld id="{846CE7D5-CF57-46EF-B807-FDD0502418D4}" type="datetimeFigureOut">
               <a:rPr lang="en-US" smtClean="0"/>
-              <a:t>7/2/26</a:t>
+              <a:t>8/4/26</a:t>
             </a:fld>
             <a:endParaRPr lang="en-US"/>
           </a:p>
@@ -2855,7 +2855,7 @@
           <a:p>
             <a:fld id="{846CE7D5-CF57-46EF-B807-FDD0502418D4}" type="datetimeFigureOut">
               <a:rPr lang="en-US" smtClean="0"/>
-              <a:t>7/2/26</a:t>
+              <a:t>8/4/26</a:t>
             </a:fld>
             <a:endParaRPr lang="en-US"/>
           </a:p>
@@ -3087,7 +3087,7 @@
           <a:p>
             <a:fld id="{846CE7D5-CF57-46EF-B807-FDD0502418D4}" type="datetimeFigureOut">
               <a:rPr lang="en-US" smtClean="0"/>
-              <a:t>7/2/26</a:t>
+              <a:t>8/4/26</a:t>
             </a:fld>
             <a:endParaRPr lang="en-US"/>
           </a:p>
@@ -3454,7 +3454,7 @@
           <a:p>
             <a:fld id="{846CE7D5-CF57-46EF-B807-FDD0502418D4}" type="datetimeFigureOut">
               <a:rPr lang="en-US" smtClean="0"/>
-              <a:t>7/2/26</a:t>
+              <a:t>8/4/26</a:t>
             </a:fld>
             <a:endParaRPr lang="en-US"/>
           </a:p>
@@ -3572,7 +3572,7 @@
           <a:p>
             <a:fld id="{846CE7D5-CF57-46EF-B807-FDD0502418D4}" type="datetimeFigureOut">
               <a:rPr lang="en-US" smtClean="0"/>
-              <a:t>7/2/26</a:t>
+              <a:t>8/4/26</a:t>
             </a:fld>
             <a:endParaRPr lang="en-US"/>
           </a:p>
@@ -3667,7 +3667,7 @@
           <a:p>
             <a:fld id="{846CE7D5-CF57-46EF-B807-FDD0502418D4}" type="datetimeFigureOut">
               <a:rPr lang="en-US" smtClean="0"/>
-              <a:t>7/2/26</a:t>
+              <a:t>8/4/26</a:t>
             </a:fld>
             <a:endParaRPr lang="en-US"/>
           </a:p>
@@ -3944,7 +3944,7 @@
           <a:p>
             <a:fld id="{846CE7D5-CF57-46EF-B807-FDD0502418D4}" type="datetimeFigureOut">
               <a:rPr lang="en-US" smtClean="0"/>
-              <a:t>7/2/26</a:t>
+              <a:t>8/4/26</a:t>
             </a:fld>
             <a:endParaRPr lang="en-US"/>
           </a:p>
@@ -4201,7 +4201,7 @@
           <a:p>
             <a:fld id="{846CE7D5-CF57-46EF-B807-FDD0502418D4}" type="datetimeFigureOut">
               <a:rPr lang="en-US" smtClean="0"/>
-              <a:t>7/2/26</a:t>
+              <a:t>8/4/26</a:t>
             </a:fld>
             <a:endParaRPr lang="en-US"/>
           </a:p>
@@ -4414,7 +4414,7 @@
           <a:p>
             <a:fld id="{846CE7D5-CF57-46EF-B807-FDD0502418D4}" type="datetimeFigureOut">
               <a:rPr lang="en-US" smtClean="0"/>
-              <a:t>7/2/26</a:t>
+              <a:t>8/4/26</a:t>
             </a:fld>
             <a:endParaRPr lang="en-US"/>
           </a:p>
@@ -6410,7 +6410,7 @@
             <p:ph idx="1"/>
             <p:extLst>
               <p:ext uri="{D42A27DB-BD31-4B8C-83A1-F6EECF244321}">
-                <p14:modId xmlns:p14="http://schemas.microsoft.com/office/powerpoint/2010/main" val="3785806349"/>
+                <p14:modId xmlns:p14="http://schemas.microsoft.com/office/powerpoint/2010/main" val="2973354579"/>
               </p:ext>
             </p:extLst>
           </p:nvPr>
@@ -6481,16 +6481,23 @@
                       <a:r>
                         <a:rPr lang="en-CA" sz="1200" b="1" i="0" u="none" strike="noStrike" dirty="0">
                           <a:solidFill>
-                            <a:srgbClr val="000000"/>
+                            <a:schemeClr val="bg1"/>
                           </a:solidFill>
                           <a:effectLst/>
                           <a:latin typeface="Aptos Narrow" panose="020B0004020202020204" pitchFamily="34" charset="0"/>
                         </a:rPr>
-                        <a:t>METRIC/INTERVAL</a:t>
+                        <a:t>METRIC/INTERVAL - Morning</a:t>
                       </a:r>
                     </a:p>
                   </a:txBody>
-                  <a:tcPr marL="9525" marR="9525" marT="9525" marB="0" anchor="ctr"/>
+                  <a:tcPr marL="9525" marR="9525" marT="9525" marB="0" anchor="ctr">
+                    <a:solidFill>
+                      <a:schemeClr val="tx2">
+                        <a:lumMod val="75000"/>
+                        <a:lumOff val="25000"/>
+                      </a:schemeClr>
+                    </a:solidFill>
+                  </a:tcPr>
                 </a:tc>
                 <a:tc>
                   <a:txBody>
@@ -6502,20 +6509,30 @@
                       </a:pPr>
                       <a:r>
                         <a:rPr lang="en-CA" sz="1200" b="1" u="none" strike="noStrike" dirty="0">
+                          <a:solidFill>
+                            <a:schemeClr val="bg1"/>
+                          </a:solidFill>
                           <a:effectLst/>
                         </a:rPr>
                         <a:t>5sec</a:t>
                       </a:r>
                       <a:endParaRPr lang="en-CA" sz="1200" b="1" i="0" u="none" strike="noStrike" dirty="0">
                         <a:solidFill>
-                          <a:srgbClr val="000000"/>
+                          <a:schemeClr val="bg1"/>
                         </a:solidFill>
                         <a:effectLst/>
                         <a:latin typeface="Aptos Narrow" panose="020B0004020202020204" pitchFamily="34" charset="0"/>
                       </a:endParaRPr>
                     </a:p>
                   </a:txBody>
-                  <a:tcPr marL="9525" marR="9525" marT="9525" marB="0" anchor="ctr"/>
+                  <a:tcPr marL="9525" marR="9525" marT="9525" marB="0" anchor="ctr">
+                    <a:solidFill>
+                      <a:schemeClr val="tx2">
+                        <a:lumMod val="75000"/>
+                        <a:lumOff val="25000"/>
+                      </a:schemeClr>
+                    </a:solidFill>
+                  </a:tcPr>
                 </a:tc>
                 <a:tc>
                   <a:txBody>
@@ -6527,20 +6544,30 @@
                       </a:pPr>
                       <a:r>
                         <a:rPr lang="en-CA" sz="1200" b="1" u="none" strike="noStrike">
+                          <a:solidFill>
+                            <a:schemeClr val="bg1"/>
+                          </a:solidFill>
                           <a:effectLst/>
                         </a:rPr>
                         <a:t>20sec</a:t>
                       </a:r>
                       <a:endParaRPr lang="en-CA" sz="1200" b="1" i="0" u="none" strike="noStrike">
                         <a:solidFill>
-                          <a:srgbClr val="000000"/>
+                          <a:schemeClr val="bg1"/>
                         </a:solidFill>
                         <a:effectLst/>
                         <a:latin typeface="Aptos Narrow" panose="020B0004020202020204" pitchFamily="34" charset="0"/>
                       </a:endParaRPr>
                     </a:p>
                   </a:txBody>
-                  <a:tcPr marL="9525" marR="9525" marT="9525" marB="0" anchor="ctr"/>
+                  <a:tcPr marL="9525" marR="9525" marT="9525" marB="0" anchor="ctr">
+                    <a:solidFill>
+                      <a:schemeClr val="tx2">
+                        <a:lumMod val="75000"/>
+                        <a:lumOff val="25000"/>
+                      </a:schemeClr>
+                    </a:solidFill>
+                  </a:tcPr>
                 </a:tc>
                 <a:tc>
                   <a:txBody>
@@ -6552,20 +6579,30 @@
                       </a:pPr>
                       <a:r>
                         <a:rPr lang="en-CA" sz="1200" b="1" u="none" strike="noStrike">
+                          <a:solidFill>
+                            <a:schemeClr val="bg1"/>
+                          </a:solidFill>
                           <a:effectLst/>
                         </a:rPr>
                         <a:t>40sec</a:t>
                       </a:r>
                       <a:endParaRPr lang="en-CA" sz="1200" b="1" i="0" u="none" strike="noStrike">
                         <a:solidFill>
-                          <a:srgbClr val="000000"/>
+                          <a:schemeClr val="bg1"/>
                         </a:solidFill>
                         <a:effectLst/>
                         <a:latin typeface="Aptos Narrow" panose="020B0004020202020204" pitchFamily="34" charset="0"/>
                       </a:endParaRPr>
                     </a:p>
                   </a:txBody>
-                  <a:tcPr marL="9525" marR="9525" marT="9525" marB="0" anchor="ctr"/>
+                  <a:tcPr marL="9525" marR="9525" marT="9525" marB="0" anchor="ctr">
+                    <a:solidFill>
+                      <a:schemeClr val="tx2">
+                        <a:lumMod val="75000"/>
+                        <a:lumOff val="25000"/>
+                      </a:schemeClr>
+                    </a:solidFill>
+                  </a:tcPr>
                 </a:tc>
                 <a:tc>
                   <a:txBody>
@@ -6577,20 +6614,30 @@
                       </a:pPr>
                       <a:r>
                         <a:rPr lang="en-CA" sz="1200" b="1" u="none" strike="noStrike">
+                          <a:solidFill>
+                            <a:schemeClr val="bg1"/>
+                          </a:solidFill>
                           <a:effectLst/>
                         </a:rPr>
                         <a:t>1min</a:t>
                       </a:r>
                       <a:endParaRPr lang="en-CA" sz="1200" b="1" i="0" u="none" strike="noStrike">
                         <a:solidFill>
-                          <a:srgbClr val="000000"/>
+                          <a:schemeClr val="bg1"/>
                         </a:solidFill>
                         <a:effectLst/>
                         <a:latin typeface="Aptos Narrow" panose="020B0004020202020204" pitchFamily="34" charset="0"/>
                       </a:endParaRPr>
                     </a:p>
                   </a:txBody>
-                  <a:tcPr marL="9525" marR="9525" marT="9525" marB="0" anchor="ctr"/>
+                  <a:tcPr marL="9525" marR="9525" marT="9525" marB="0" anchor="ctr">
+                    <a:solidFill>
+                      <a:schemeClr val="tx2">
+                        <a:lumMod val="75000"/>
+                        <a:lumOff val="25000"/>
+                      </a:schemeClr>
+                    </a:solidFill>
+                  </a:tcPr>
                 </a:tc>
                 <a:tc>
                   <a:txBody>
@@ -6603,16 +6650,23 @@
                       <a:r>
                         <a:rPr lang="en-CA" sz="1200" b="1" i="0" u="none" strike="noStrike" dirty="0">
                           <a:solidFill>
-                            <a:srgbClr val="000000"/>
+                            <a:schemeClr val="bg1"/>
                           </a:solidFill>
                           <a:effectLst/>
                           <a:latin typeface="Aptos Narrow" panose="020B0004020202020204" pitchFamily="34" charset="0"/>
                         </a:rPr>
-                        <a:t>average</a:t>
+                        <a:t>Average</a:t>
                       </a:r>
                     </a:p>
                   </a:txBody>
-                  <a:tcPr marL="9525" marR="9525" marT="9525" marB="0" anchor="ctr"/>
+                  <a:tcPr marL="9525" marR="9525" marT="9525" marB="0" anchor="ctr">
+                    <a:solidFill>
+                      <a:schemeClr val="tx2">
+                        <a:lumMod val="75000"/>
+                        <a:lumOff val="25000"/>
+                      </a:schemeClr>
+                    </a:solidFill>
+                  </a:tcPr>
                 </a:tc>
                 <a:extLst>
                   <a:ext uri="{0D108BD9-81ED-4DB2-BD59-A6C34878D82A}">
@@ -6758,7 +6812,7 @@
                         <a:rPr lang="en-CA" sz="1200" u="none" strike="noStrike" dirty="0">
                           <a:effectLst/>
                         </a:rPr>
-                        <a:t>N?A </a:t>
+                        <a:t>N/A </a:t>
                       </a:r>
                       <a:endParaRPr lang="en-CA" sz="1200" b="0" i="0" u="none" strike="noStrike" dirty="0">
                         <a:solidFill>
@@ -6837,12 +6891,12 @@
                         <a:buNone/>
                       </a:pPr>
                       <a:r>
-                        <a:rPr lang="en-CA" sz="1200" u="none" strike="noStrike">
+                        <a:rPr lang="en-CA" sz="1200" u="none" strike="noStrike" dirty="0">
                           <a:effectLst/>
                         </a:rPr>
                         <a:t>N/A</a:t>
                       </a:r>
-                      <a:endParaRPr lang="en-CA" sz="1200" b="0" i="0" u="none" strike="noStrike">
+                      <a:endParaRPr lang="en-CA" sz="1200" b="0" i="0" u="none" strike="noStrike" dirty="0">
                         <a:solidFill>
                           <a:srgbClr val="000000"/>
                         </a:solidFill>
@@ -7019,12 +7073,12 @@
                         <a:buNone/>
                       </a:pPr>
                       <a:r>
-                        <a:rPr lang="en-CA" sz="1200" u="none" strike="noStrike">
+                        <a:rPr lang="en-CA" sz="1200" u="none" strike="noStrike" dirty="0">
                           <a:effectLst/>
                         </a:rPr>
                         <a:t>2</a:t>
                       </a:r>
-                      <a:endParaRPr lang="en-CA" sz="1200" b="0" i="0" u="none" strike="noStrike">
+                      <a:endParaRPr lang="en-CA" sz="1200" b="0" i="0" u="none" strike="noStrike" dirty="0">
                         <a:solidFill>
                           <a:srgbClr val="000000"/>
                         </a:solidFill>
@@ -7226,12 +7280,12 @@
                         <a:buNone/>
                       </a:pPr>
                       <a:r>
-                        <a:rPr lang="en-CA" sz="1200" u="none" strike="noStrike">
+                        <a:rPr lang="en-CA" sz="1200" u="none" strike="noStrike" dirty="0">
                           <a:effectLst/>
                         </a:rPr>
                         <a:t>-138.59604</a:t>
                       </a:r>
-                      <a:endParaRPr lang="en-CA" sz="1200" b="0" i="0" u="none" strike="noStrike">
+                      <a:endParaRPr lang="en-CA" sz="1200" b="0" i="0" u="none" strike="noStrike" dirty="0">
                         <a:solidFill>
                           <a:srgbClr val="000000"/>
                         </a:solidFill>
@@ -7258,12 +7312,12 @@
                         <a:buNone/>
                       </a:pPr>
                       <a:r>
-                        <a:rPr lang="en-CA" sz="1200" b="1" u="none" strike="noStrike">
+                        <a:rPr lang="en-CA" sz="1200" b="1" u="none" strike="noStrike" dirty="0">
                           <a:effectLst/>
                         </a:rPr>
                         <a:t>RSSI SD (outgoing)</a:t>
                       </a:r>
-                      <a:endParaRPr lang="en-CA" sz="1200" b="1" i="0" u="none" strike="noStrike">
+                      <a:endParaRPr lang="en-CA" sz="1200" b="1" i="0" u="none" strike="noStrike" dirty="0">
                         <a:solidFill>
                           <a:srgbClr val="000000"/>
                         </a:solidFill>
@@ -7804,12 +7858,12 @@
                         <a:buNone/>
                       </a:pPr>
                       <a:r>
-                        <a:rPr lang="en-CA" sz="1200" u="none" strike="noStrike">
+                        <a:rPr lang="en-CA" sz="1200" u="none" strike="noStrike" dirty="0">
                           <a:effectLst/>
                         </a:rPr>
                         <a:t>50</a:t>
                       </a:r>
-                      <a:endParaRPr lang="en-CA" sz="1200" b="0" i="0" u="none" strike="noStrike">
+                      <a:endParaRPr lang="en-CA" sz="1200" b="0" i="0" u="none" strike="noStrike" dirty="0">
                         <a:solidFill>
                           <a:srgbClr val="000000"/>
                         </a:solidFill>
@@ -8014,7 +8068,7 @@
                         <a:rPr lang="en-CA" sz="1200" u="none" strike="noStrike" dirty="0">
                           <a:effectLst/>
                         </a:rPr>
-                        <a:t> N?A</a:t>
+                        <a:t> N/A</a:t>
                       </a:r>
                       <a:endParaRPr lang="en-CA" sz="1200" b="0" i="0" u="none" strike="noStrike" dirty="0">
                         <a:solidFill>
@@ -8300,12 +8354,12 @@
                         <a:buNone/>
                       </a:pPr>
                       <a:r>
-                        <a:rPr lang="en-CA" sz="1200" u="none" strike="noStrike">
+                        <a:rPr lang="en-CA" sz="1200" u="none" strike="noStrike" dirty="0">
                           <a:effectLst/>
                         </a:rPr>
                         <a:t>15.1825622</a:t>
                       </a:r>
-                      <a:endParaRPr lang="en-CA" sz="1200" b="0" i="0" u="none" strike="noStrike">
+                      <a:endParaRPr lang="en-CA" sz="1200" b="0" i="0" u="none" strike="noStrike" dirty="0">
                         <a:solidFill>
                           <a:srgbClr val="000000"/>
                         </a:solidFill>
@@ -8457,12 +8511,12 @@
                         <a:buNone/>
                       </a:pPr>
                       <a:r>
-                        <a:rPr lang="en-CA" sz="1200" u="none" strike="noStrike">
+                        <a:rPr lang="en-CA" sz="1200" u="none" strike="noStrike" dirty="0">
                           <a:effectLst/>
                         </a:rPr>
                         <a:t>-1.1197917</a:t>
                       </a:r>
-                      <a:endParaRPr lang="en-CA" sz="1200" b="0" i="0" u="none" strike="noStrike">
+                      <a:endParaRPr lang="en-CA" sz="1200" b="0" i="0" u="none" strike="noStrike" dirty="0">
                         <a:solidFill>
                           <a:srgbClr val="000000"/>
                         </a:solidFill>

</xml_diff>